<commit_message>
Presentazione alla scuola: slide 4 con le 20 domande del quiz base per materia, piè di pagina «entro le 12 miglia e senza limiti dalla costa», export e README
Co-Authored-By: Claude Opus 5.5 <noreply@anthropic.com>
Claude-Session: https://claude.ai/code/session_01JPL34mYzgWNhRELUonzupj
</commit_message>
<xml_diff>
--- a/corso/export/pptx/Rotta verso la patente - Il corso in sintesi.pptx
+++ b/corso/export/pptx/Rotta verso la patente - Il corso in sintesi.pptx
@@ -12,6 +12,7 @@
     <p:sldId id="260" r:id="rId12"/>
     <p:sldId id="261" r:id="rId13"/>
     <p:sldId id="262" r:id="rId14"/>
+    <p:sldId id="263" r:id="rId15"/>
   </p:sldIdLst>
   <p:sldSz cx="12192000" cy="6858000" type="screen4x3"/>
   <p:notesSz cx="6858000" cy="9144000"/>
@@ -508,7 +509,7 @@
           <a:lstStyle/>
           <a:p>
             <a:r>
-              <a:t>[40 secondi · minuto 0:40] Buongiorno e grazie del tempo. Sono Fabrizio Fiorucci, skipper e istruttore di vela. Vi presento «Rotta verso la Patente Nautica da Diporto», un corso completo per la patente vela e motore senza limiti dalla costa, pronto da usare subito in aula e in barca. Cinque numeri per inquadrarlo: 30 ore di lezione, 15 lezioni, 13 appendici di ripasso, tutti i 135 esercizi di carteggio d'esame svolti, e oltre mille slide già illustrate. In sette slide vi mostro com'è costruito, a chi serve e perché può funzionare bene nella vostra scuola.</a:t>
+              <a:t>[40 secondi · minuto 0:40] Buongiorno e grazie del tempo. Sono Fabrizio Fiorucci, skipper e istruttore di vela. Vi presento «Rotta verso la Patente Nautica da Diporto», un corso completo per la patente vela e motore entro le 12 miglia e senza limiti dalla costa, pronto da usare subito in aula e in barca. Cinque numeri per inquadrarlo: 30 ore di lezione, 15 lezioni, 13 appendici di ripasso, tutti i 135 esercizi di carteggio d'esame svolti, e oltre mille slide già illustrate. In otto slide vi mostro com'è costruito, a chi serve e perché può funzionare bene nella vostra scuola.</a:t>
             </a:r>
           </a:p>
         </p:txBody>
@@ -718,7 +719,7 @@
           <a:lstStyle/>
           <a:p>
             <a:r>
-              <a:t>[70 secondi · minuto 4:20] Seconda scelta per l'allievo: vela e motore, oppure solo motore. Con il solo motore l'esame scritto comprende carteggio e quiz base, senza quiz vela; la pratica è a motore: ormeggio e disormeggio, uomo a mare, nodi, uso degli strumenti. In aula si seguono tutte le lezioni tranne la 9 sulla vela: 16 ore per la patente entro 12 miglia, 28 per quella senza limiti. Con vela e motore si aggiungono i 5 quiz vela, 15 minuti con al massimo un errore, e la pratica comprende andature e manovre a vela oltre a tutto il programma a motore, con l'istruttore di vela a bordo. In aula anche la lezione 9 e l'appendice sui nomi della barca a vela: 18 ore entro 12 miglia, 30 senza limiti. E se la prova a vela non va? L'allievo può scegliere la patente a solo motore facendo le manovre a motore: non perde l'esame. Anche qui, lo stesso materiale serve entrambi i percorsi.</a:t>
+              <a:t>[40 secondi · minuto 3:50] Come sono fatte le 20 domande del quiz base, uguale per entrambe le patenti, entro 12 miglia e senza limiti. L'Allegato C al DM 323/2021 le ripartisce per materia: navigazione cartografica 4, manovra e condotta 4, sicurezza 3, normativa 3, COLREG e segnalamento 2, meteorologia 2, teoria dello scafo 1, motori 1. Alcune materie si studiano in più lezioni: la navigazione nelle lezioni 3, 4, 5 e 8; la manovra nelle 3, 4 e 6; COLREG e segnalamento nelle 3, 5 e 6; la teoria dello scafo nelle 1 e 2. Ma all'esame ogni materia vale sempre lo stesso numero di domande: le 4 domande di navigazione sono 4 in tutto, non 4 per ogni lezione. Per questo in ogni lezione l'agenda e la raccolta quiz mostrano questa stessa tabella da 20, con evidenziate le materie del giorno: l'allievo sa sempre quanto pesa quello che sta studiando.</a:t>
             </a:r>
           </a:p>
         </p:txBody>
@@ -788,7 +789,7 @@
           <a:lstStyle/>
           <a:p>
             <a:r>
-              <a:t>[70 secondi · minuto 5:30] Che cosa sapranno fare gli allievi alla fine? Sei competenze. Conoscere la barca: scafo, motori, elica, timone, attrezzatura e vele, ogni parte con il suo nome e la sua funzione. Navigare sicuri: precedenze, fanali, segnali sonori e segnalamento, sapere chi passa e dove. Fare il carteggio: punto nave, prora e rotta, carburante, scarroccio e correnti sulle due carte d'esame. Leggere il tempo: pressione, venti e brezze, fronti, onde e bollettini, per decidere se e quando uscire. Gestire l'emergenza: uomo a mare, falla, incendio, abbandono, radio VHF e MAYDAY, sapendo cosa fare e in che ordine. E comandare la barca: manovre, ormeggio e ancoraggio, nodi, documenti, dotazioni e responsabilità del comandante. Il nostro obiettivo non è solo passare l'esame: è uscire in mare sapendo cosa fare.</a:t>
+              <a:t>[70 secondi · minuto 5:00] Seconda scelta per l'allievo: vela e motore, oppure solo motore. Con il solo motore l'esame scritto comprende carteggio e quiz base, senza quiz vela; la pratica è a motore: ormeggio e disormeggio, uomo a mare, nodi, uso degli strumenti. In aula si seguono tutte le lezioni tranne la 9 sulla vela: 16 ore per la patente entro 12 miglia, 28 per quella senza limiti. Con vela e motore si aggiungono i 5 quiz vela, 15 minuti con al massimo un errore, e la pratica comprende andature e manovre a vela oltre a tutto il programma a motore, con l'istruttore di vela a bordo. In aula anche la lezione 9 e l'appendice sui nomi della barca a vela: 18 ore entro 12 miglia, 30 senza limiti. E se la prova a vela non va? L'allievo può scegliere la patente a solo motore facendo le manovre a motore: non perde l'esame. Anche qui, lo stesso materiale serve entrambi i percorsi.</a:t>
             </a:r>
           </a:p>
         </p:txBody>
@@ -858,7 +859,7 @@
           <a:lstStyle/>
           <a:p>
             <a:r>
-              <a:t>[70 secondi · minuto 6:40] Il materiale è già tutto pronto: oltre mille slide illustrate, ognuna con le note per l'istruttore. Quindici lezioni da due ore, 594 slide con disegni originali, schemi e quiz ufficiali seguiti dalle risposte. I 135 esercizi di carteggio, tutti svolti: la traccia, la soluzione e il tracciamento sulla carta. Tredici appendici, 489 slide: correnti, nomi della barca, nodi, segnali IALA, normativa, radio VHF, navigazione sottocosta, meteo, soccorso, ancoraggio e portanza. Venti prove d'esame simulate complete, dieci entro e dieci oltre 12 miglia, con le soluzioni. La prova pratica spiegata manovra per manovra, secondo l'Allegato D. E quindici schede riassuntive da stampare per gli allievi. In pratica: si accende il proiettore e si salpa. I deck si proiettano dal browser e si possono scaricare in PDF o PowerPoint.</a:t>
+              <a:t>[70 secondi · minuto 6:10] Che cosa sapranno fare gli allievi alla fine? Sei competenze. Conoscere la barca: scafo, motori, elica, timone, attrezzatura e vele, ogni parte con il suo nome e la sua funzione. Navigare sicuri: precedenze, fanali, segnali sonori e segnalamento, sapere chi passa e dove. Fare il carteggio: punto nave, prora e rotta, carburante, scarroccio e correnti sulle due carte d'esame. Leggere il tempo: pressione, venti e brezze, fronti, onde e bollettini, per decidere se e quando uscire. Gestire l'emergenza: uomo a mare, falla, incendio, abbandono, radio VHF e MAYDAY, sapendo cosa fare e in che ordine. E comandare la barca: manovre, ormeggio e ancoraggio, nodi, documenti, dotazioni e responsabilità del comandante. Il nostro obiettivo non è solo passare l'esame: è uscire in mare sapendo cosa fare.</a:t>
             </a:r>
           </a:p>
         </p:txBody>
@@ -928,7 +929,77 @@
           <a:lstStyle/>
           <a:p>
             <a:r>
-              <a:t>[60 secondi · minuto 7:40] Per chiudere, sei ragioni per scegliere questo corso. È allineato all'esame: segue il programma del DM 323 del 2021 e usa quiz ed esercizi dell'elenco ufficiale del decreto dirigenziale 131 del 2022. Nessun esercizio resta indietro: 135 esercizi di carteggio su 135, svolti e tracciati. Si impara guardando: ogni lezione ha disegni originali di barche, manovre, carte, luci e segnali. La verifica è continua: quiz ufficiali in ogni lezione, sempre seguiti dalla slide con le risposte. È aggiornato: le dotazioni di sicurezza seguono il DM 133 del 2024. Ed è pronto per la scuola: note per l'istruttore, PDF e PowerPoint, schede da dare agli allievi. Pronti a salpare? Grazie, sono a disposizione per le vostre domande.</a:t>
+              <a:t>[70 secondi · minuto 7:20] Il materiale è già tutto pronto: oltre mille slide illustrate, ognuna con le note per l'istruttore. Quindici lezioni da due ore, 594 slide con disegni originali, schemi e quiz ufficiali seguiti dalle risposte. I 135 esercizi di carteggio, tutti svolti: la traccia, la soluzione e il tracciamento sulla carta. Tredici appendici, 489 slide: correnti, nomi della barca, nodi, segnali IALA, normativa, radio VHF, navigazione sottocosta, meteo, soccorso, ancoraggio e portanza. Venti prove d'esame simulate complete, dieci entro e dieci oltre 12 miglia, con le soluzioni. La prova pratica spiegata manovra per manovra, secondo l'Allegato D. E quindici schede riassuntive da stampare per gli allievi. In pratica: si accende il proiettore e si salpa. I deck si proiettano dal browser e si possono scaricare in PDF o PowerPoint.</a:t>
+            </a:r>
+          </a:p>
+        </p:txBody>
+      </p:sp>
+      <p:sp>
+        <p:nvSpPr>
+          <p:cNvPr id="4" name="Slide Number Placeholder 3"/>
+          <p:cNvSpPr>
+            <a:spLocks noGrp="1"/>
+          </p:cNvSpPr>
+          <p:nvPr>
+            <p:ph type="sldNum" idx="5" sz="quarter"/>
+          </p:nvPr>
+        </p:nvSpPr>
+        <p:spPr/>
+      </p:sp>
+    </p:spTree>
+  </p:cSld>
+  <p:clrMapOvr>
+    <a:masterClrMapping/>
+  </p:clrMapOvr>
+</p:notes>
+</file>
+
+<file path=ppt/notesSlides/notesSlide8.xml><?xml version="1.0" encoding="utf-8"?>
+<p:notes xmlns:a="http://schemas.openxmlformats.org/drawingml/2006/main" xmlns:p="http://schemas.openxmlformats.org/presentationml/2006/main" xmlns:r="http://schemas.openxmlformats.org/officeDocument/2006/relationships">
+  <p:cSld>
+    <p:spTree>
+      <p:nvGrpSpPr>
+        <p:cNvPr id="1" name=""/>
+        <p:cNvGrpSpPr/>
+        <p:nvPr/>
+      </p:nvGrpSpPr>
+      <p:grpSpPr>
+        <a:xfrm>
+          <a:off x="0" y="0"/>
+          <a:ext cx="0" cy="0"/>
+          <a:chOff x="0" y="0"/>
+          <a:chExt cx="0" cy="0"/>
+        </a:xfrm>
+      </p:grpSpPr>
+      <p:sp>
+        <p:nvSpPr>
+          <p:cNvPr id="2" name="Slide Image Placeholder 1"/>
+          <p:cNvSpPr>
+            <a:spLocks noGrp="1"/>
+          </p:cNvSpPr>
+          <p:nvPr>
+            <p:ph type="sldImg" idx="2"/>
+          </p:nvPr>
+        </p:nvSpPr>
+        <p:spPr/>
+      </p:sp>
+      <p:sp>
+        <p:nvSpPr>
+          <p:cNvPr id="3" name="Notes Placeholder 2"/>
+          <p:cNvSpPr>
+            <a:spLocks noGrp="1"/>
+          </p:cNvSpPr>
+          <p:nvPr>
+            <p:ph type="body" idx="3" sz="quarter"/>
+          </p:nvPr>
+        </p:nvSpPr>
+        <p:spPr/>
+        <p:txBody>
+          <a:bodyPr/>
+          <a:lstStyle/>
+          <a:p>
+            <a:r>
+              <a:t>[60 secondi · minuto 8:20] Per chiudere, sei ragioni per scegliere questo corso. È allineato all'esame: segue il programma del DM 323 del 2021 e usa quiz ed esercizi dell'elenco ufficiale del decreto dirigenziale 131 del 2022. Nessun esercizio resta indietro: 135 esercizi di carteggio su 135, svolti e tracciati. Si impara guardando: ogni lezione ha disegni originali di barche, manovre, carte, luci e segnali. La verifica è continua: quiz ufficiali in ogni lezione, sempre seguiti dalla slide con le risposte. È aggiornato: le dotazioni di sicurezza seguono il DM 133 del 2024. Ed è pronto per la scuola: note per l'istruttore, PDF e PowerPoint, schede da dare agli allievi. Pronti a salpare? Grazie, sono a disposizione per le vostre domande.</a:t>
             </a:r>
           </a:p>
         </p:txBody>
@@ -4177,6 +4248,48 @@
 </file>
 
 <file path=ppt/slides/slide7.xml><?xml version="1.0" encoding="utf-8"?>
+<p:sld xmlns:a="http://schemas.openxmlformats.org/drawingml/2006/main" xmlns:p="http://schemas.openxmlformats.org/presentationml/2006/main" xmlns:r="http://schemas.openxmlformats.org/officeDocument/2006/relationships">
+  <p:cSld>
+    <p:spTree>
+      <p:nvGrpSpPr>
+        <p:cNvPr id="1" name=""/>
+        <p:cNvGrpSpPr/>
+        <p:nvPr/>
+      </p:nvGrpSpPr>
+      <p:grpSpPr/>
+      <p:pic>
+        <p:nvPicPr>
+          <p:cNvPr id="2" name="Picture 1" descr="image.jpg"/>
+          <p:cNvPicPr>
+            <a:picLocks noChangeAspect="1"/>
+          </p:cNvPicPr>
+          <p:nvPr/>
+        </p:nvPicPr>
+        <p:blipFill>
+          <a:blip r:embed="rId2"/>
+          <a:stretch>
+            <a:fillRect/>
+          </a:stretch>
+        </p:blipFill>
+        <p:spPr>
+          <a:xfrm>
+            <a:off x="0" y="0"/>
+            <a:ext cx="12192000" cy="6858000"/>
+          </a:xfrm>
+          <a:prstGeom prst="rect">
+            <a:avLst/>
+          </a:prstGeom>
+        </p:spPr>
+      </p:pic>
+    </p:spTree>
+  </p:cSld>
+  <p:clrMapOvr>
+    <a:masterClrMapping/>
+  </p:clrMapOvr>
+</p:sld>
+</file>
+
+<file path=ppt/slides/slide8.xml><?xml version="1.0" encoding="utf-8"?>
 <p:sld xmlns:a="http://schemas.openxmlformats.org/drawingml/2006/main" xmlns:p="http://schemas.openxmlformats.org/presentationml/2006/main" xmlns:r="http://schemas.openxmlformats.org/officeDocument/2006/relationships">
   <p:cSld>
     <p:spTree>

</xml_diff>